<commit_message>
Retitle deck: "What the Data Says, and What Singapore Taught Me"
Sized the title line down to 46pt and widened the box to fit the longer
second line; deck metadata updated to match.

Co-Authored-By: Claude Opus 5 <noreply@anthropic.com>
Claude-Session: https://claude.ai/code/session_01EcWbN9Apj1bv5rBPTf4Vde
</commit_message>
<xml_diff>
--- a/catos-farewell/CATOS_Farewell_Ferrara_Aug2026.pptx
+++ b/catos-farewell/CATOS_Farewell_Ferrara_Aug2026.pptx
@@ -5010,7 +5010,7 @@
         <p:spPr>
           <a:xfrm>
             <a:off x="640080" y="1737360"/>
-            <a:ext cx="9601200" cy="2011680"/>
+            <a:ext cx="10607040" cy="2011680"/>
           </a:xfrm>
           <a:prstGeom prst="rect">
             <a:avLst/>
@@ -5024,12 +5024,12 @@
           <a:p>
             <a:pPr indent="0" marL="0">
               <a:lnSpc>
-                <a:spcPts val="5600"/>
+                <a:spcPts val="5400"/>
               </a:lnSpc>
               <a:buNone/>
             </a:pPr>
             <a:r>
-              <a:rPr lang="en-US" sz="5000" b="1" dirty="0">
+              <a:rPr lang="en-US" sz="4600" b="1" dirty="0">
                 <a:solidFill>
                   <a:srgbClr val="FFFFFF"/>
                 </a:solidFill>
@@ -5037,19 +5037,19 @@
                 <a:ea typeface="Cambria" pitchFamily="34" charset="-122"/>
                 <a:cs typeface="Cambria" pitchFamily="34" charset="-120"/>
               </a:rPr>
-              <a:t>What the Data Said,</a:t>
-            </a:r>
-            <a:endParaRPr lang="en-US" sz="5000" dirty="0"/>
+              <a:t>What the Data Says,</a:t>
+            </a:r>
+            <a:endParaRPr lang="en-US" sz="4600" dirty="0"/>
           </a:p>
           <a:p>
             <a:pPr indent="0" marL="0">
               <a:lnSpc>
-                <a:spcPts val="5600"/>
+                <a:spcPts val="5400"/>
               </a:lnSpc>
               <a:buNone/>
             </a:pPr>
             <a:r>
-              <a:rPr lang="en-US" sz="5000" b="1" dirty="0">
+              <a:rPr lang="en-US" sz="4600" b="1" dirty="0">
                 <a:solidFill>
                   <a:srgbClr val="FFFFFF"/>
                 </a:solidFill>
@@ -5057,9 +5057,9 @@
                 <a:ea typeface="Cambria" pitchFamily="34" charset="-122"/>
                 <a:cs typeface="Cambria" pitchFamily="34" charset="-120"/>
               </a:rPr>
-              <a:t>and What It Taught Us</a:t>
-            </a:r>
-            <a:endParaRPr lang="en-US" sz="5000" dirty="0"/>
+              <a:t>and What Singapore Taught Me</a:t>
+            </a:r>
+            <a:endParaRPr lang="en-US" sz="4600" dirty="0"/>
           </a:p>
         </p:txBody>
       </p:sp>

</xml_diff>

<commit_message>
Fix three defects found in visual review; add rendered PDF
Rendering works now: the container had only libreoffice-core (no import
filter for any format, hence "source file could not be loaded" on every
file), and Calibri was falling back to DejaVu Sans, which is ~30% wider and
showed wrapping that would not occur in PowerPoint. Installing
libreoffice-impress and fonts-crosextra-carlito fixes both; noted in OUTLINE.md.

Defects found by actually looking at the slides:
- recall chart axis extended below zero on the paraphrase-cliff slide
- the closing card on "Five things I'd tell whoever picks this up" sat on
  top of the fifth row
- the AutoModerator artefact bar was coloured as if it were a finding

qa_geometry.py now also flags panel-on-panel collisions, which is the class
of defect that let the row overlap through.

Co-Authored-By: Claude Opus 5 <noreply@anthropic.com>
Claude-Session: https://claude.ai/code/session_01EcWbN9Apj1bv5rBPTf4Vde
</commit_message>
<xml_diff>
--- a/catos-farewell/CATOS_Farewell_Ferrara_Aug2026.pptx
+++ b/catos-farewell/CATOS_Farewell_Ferrara_Aug2026.pptx
@@ -492,7 +492,7 @@
           </c:tx>
           <c:spPr>
             <a:solidFill>
-              <a:srgbClr val="7A7A7A"/>
+              <a:srgbClr val="C9C2B8"/>
             </a:solidFill>
             <a:effectLst/>
           </c:spPr>
@@ -527,7 +527,7 @@
             <c:bubble3D val="0"/>
             <c:spPr>
               <a:solidFill>
-                <a:srgbClr val="7A7A7A"/>
+                <a:srgbClr val="C9C2B8"/>
               </a:solidFill>
               <a:effectLst/>
             </c:spPr>
@@ -1259,6 +1259,7 @@
         <c:scaling>
           <c:orientation val="minMax"/>
           <c:max val="0.6"/>
+          <c:min val="0"/>
         </c:scaling>
         <c:delete val="0"/>
         <c:axPos val="l"/>
@@ -20232,7 +20233,7 @@
         </p:nvSpPr>
         <p:spPr>
           <a:xfrm>
-            <a:off x="914400" y="2560320"/>
+            <a:off x="914400" y="2514600"/>
             <a:ext cx="457200" cy="548640"/>
           </a:xfrm>
           <a:prstGeom prst="rect">
@@ -20271,7 +20272,7 @@
         </p:nvSpPr>
         <p:spPr>
           <a:xfrm>
-            <a:off x="1508760" y="2532888"/>
+            <a:off x="1508760" y="2487168"/>
             <a:ext cx="5120640" cy="594360"/>
           </a:xfrm>
           <a:prstGeom prst="rect">
@@ -20310,7 +20311,7 @@
         </p:nvSpPr>
         <p:spPr>
           <a:xfrm>
-            <a:off x="6766560" y="2532888"/>
+            <a:off x="6766560" y="2487168"/>
             <a:ext cx="4480560" cy="594360"/>
           </a:xfrm>
           <a:prstGeom prst="rect">
@@ -20349,7 +20350,7 @@
         </p:nvSpPr>
         <p:spPr>
           <a:xfrm>
-            <a:off x="640080" y="3282696"/>
+            <a:off x="640080" y="3191256"/>
             <a:ext cx="10881360" cy="786384"/>
           </a:xfrm>
           <a:prstGeom prst="roundRect">
@@ -20376,7 +20377,7 @@
         </p:nvSpPr>
         <p:spPr>
           <a:xfrm>
-            <a:off x="914400" y="3383280"/>
+            <a:off x="914400" y="3291840"/>
             <a:ext cx="457200" cy="548640"/>
           </a:xfrm>
           <a:prstGeom prst="rect">
@@ -20415,7 +20416,7 @@
         </p:nvSpPr>
         <p:spPr>
           <a:xfrm>
-            <a:off x="1508760" y="3355848"/>
+            <a:off x="1508760" y="3264408"/>
             <a:ext cx="5120640" cy="594360"/>
           </a:xfrm>
           <a:prstGeom prst="rect">
@@ -20454,7 +20455,7 @@
         </p:nvSpPr>
         <p:spPr>
           <a:xfrm>
-            <a:off x="6766560" y="3355848"/>
+            <a:off x="6766560" y="3264408"/>
             <a:ext cx="4480560" cy="594360"/>
           </a:xfrm>
           <a:prstGeom prst="rect">
@@ -20493,7 +20494,7 @@
         </p:nvSpPr>
         <p:spPr>
           <a:xfrm>
-            <a:off x="914400" y="4206240"/>
+            <a:off x="914400" y="4069080"/>
             <a:ext cx="457200" cy="548640"/>
           </a:xfrm>
           <a:prstGeom prst="rect">
@@ -20532,7 +20533,7 @@
         </p:nvSpPr>
         <p:spPr>
           <a:xfrm>
-            <a:off x="1508760" y="4178808"/>
+            <a:off x="1508760" y="4041648"/>
             <a:ext cx="5120640" cy="594360"/>
           </a:xfrm>
           <a:prstGeom prst="rect">
@@ -20571,7 +20572,7 @@
         </p:nvSpPr>
         <p:spPr>
           <a:xfrm>
-            <a:off x="6766560" y="4178808"/>
+            <a:off x="6766560" y="4041648"/>
             <a:ext cx="4480560" cy="594360"/>
           </a:xfrm>
           <a:prstGeom prst="rect">
@@ -20610,7 +20611,7 @@
         </p:nvSpPr>
         <p:spPr>
           <a:xfrm>
-            <a:off x="640080" y="4928616"/>
+            <a:off x="640080" y="4745736"/>
             <a:ext cx="10881360" cy="786384"/>
           </a:xfrm>
           <a:prstGeom prst="roundRect">
@@ -20637,7 +20638,7 @@
         </p:nvSpPr>
         <p:spPr>
           <a:xfrm>
-            <a:off x="914400" y="5029200"/>
+            <a:off x="914400" y="4846320"/>
             <a:ext cx="457200" cy="548640"/>
           </a:xfrm>
           <a:prstGeom prst="rect">
@@ -20676,7 +20677,7 @@
         </p:nvSpPr>
         <p:spPr>
           <a:xfrm>
-            <a:off x="1508760" y="5001768"/>
+            <a:off x="1508760" y="4818888"/>
             <a:ext cx="5120640" cy="594360"/>
           </a:xfrm>
           <a:prstGeom prst="rect">
@@ -20715,7 +20716,7 @@
         </p:nvSpPr>
         <p:spPr>
           <a:xfrm>
-            <a:off x="6766560" y="5001768"/>
+            <a:off x="6766560" y="4818888"/>
             <a:ext cx="4480560" cy="594360"/>
           </a:xfrm>
           <a:prstGeom prst="rect">
@@ -20754,12 +20755,12 @@
         </p:nvSpPr>
         <p:spPr>
           <a:xfrm>
-            <a:off x="640080" y="5532120"/>
-            <a:ext cx="10881360" cy="822960"/>
+            <a:off x="640080" y="5577840"/>
+            <a:ext cx="10881360" cy="777240"/>
           </a:xfrm>
           <a:prstGeom prst="roundRect">
             <a:avLst>
-              <a:gd name="adj" fmla="val 5556"/>
+              <a:gd name="adj" fmla="val 5882"/>
             </a:avLst>
           </a:prstGeom>
           <a:solidFill>
@@ -20781,7 +20782,7 @@
         </p:nvSpPr>
         <p:spPr>
           <a:xfrm>
-            <a:off x="1005840" y="5577840"/>
+            <a:off x="1005840" y="5596128"/>
             <a:ext cx="10149840" cy="731520"/>
           </a:xfrm>
           <a:prstGeom prst="rect">

</xml_diff>